<commit_message>
Modified Week 2 and Singleton solution added
</commit_message>
<xml_diff>
--- a/Woche_2_DesignPatterns_I/02_Design_Patterns_I_v01.pptx
+++ b/Woche_2_DesignPatterns_I/02_Design_Patterns_I_v01.pptx
@@ -4,6 +4,9 @@
   <p:sldMasterIdLst>
     <p:sldMasterId id="2147483750" r:id="rId1"/>
   </p:sldMasterIdLst>
+  <p:notesMasterIdLst>
+    <p:notesMasterId r:id="rId54"/>
+  </p:notesMasterIdLst>
   <p:sldIdLst>
     <p:sldId id="256" r:id="rId2"/>
     <p:sldId id="257" r:id="rId3"/>
@@ -170,16 +173,11 @@
         </p15:guide>
       </p15:sldGuideLst>
     </p:ext>
+    <p:ext uri="{2D200454-40CA-4A62-9FC3-DE9A4176ACB9}">
+      <p15:notesGuideLst xmlns:p15="http://schemas.microsoft.com/office/powerpoint/2012/main"/>
+    </p:ext>
   </p:extLst>
 </p:presentation>
-</file>
-
-<file path=ppt/revisionInfo.xml><?xml version="1.0" encoding="utf-8"?>
-<p1510:revInfo xmlns:a="http://schemas.openxmlformats.org/drawingml/2006/main" xmlns:r="http://schemas.openxmlformats.org/officeDocument/2006/relationships" xmlns:p1510="http://schemas.microsoft.com/office/powerpoint/2015/10/main">
-  <p1510:revLst>
-    <p1510:client id="{FA2062A3-A281-4DB5-BC3C-2D65F072144E}" v="15" dt="2026-03-23T16:17:48.568"/>
-  </p1510:revLst>
-</p1510:revInfo>
 </file>
 
 <file path=ppt/changesInfos/changesInfo1.xml><?xml version="1.0" encoding="utf-8"?>
@@ -1363,8 +1361,8 @@
   </pc:docChgLst>
   <pc:docChgLst>
     <pc:chgData name="Peter Bernhardt" userId="f2333933-0b12-4d6e-972f-f87625423892" providerId="ADAL" clId="{34DA1458-4058-4912-885C-C6A06A12728D}"/>
-    <pc:docChg chg="undo custSel addSld delSld modSld">
-      <pc:chgData name="Peter Bernhardt" userId="f2333933-0b12-4d6e-972f-f87625423892" providerId="ADAL" clId="{34DA1458-4058-4912-885C-C6A06A12728D}" dt="2026-03-23T16:19:38.797" v="713" actId="313"/>
+    <pc:docChg chg="undo custSel addSld delSld modSld modNotesMaster">
+      <pc:chgData name="Peter Bernhardt" userId="f2333933-0b12-4d6e-972f-f87625423892" providerId="ADAL" clId="{34DA1458-4058-4912-885C-C6A06A12728D}" dt="2026-03-26T14:45:12.464" v="720" actId="6549"/>
       <pc:docMkLst>
         <pc:docMk/>
       </pc:docMkLst>
@@ -1398,30 +1396,6 @@
             <ac:spMk id="4" creationId="{00000000-0000-0000-0000-000000000000}"/>
           </ac:spMkLst>
         </pc:spChg>
-        <pc:spChg chg="add del mod">
-          <ac:chgData name="Peter Bernhardt" userId="f2333933-0b12-4d6e-972f-f87625423892" providerId="ADAL" clId="{34DA1458-4058-4912-885C-C6A06A12728D}" dt="2026-03-23T15:45:36.362" v="2" actId="6264"/>
-          <ac:spMkLst>
-            <pc:docMk/>
-            <pc:sldMk cId="0" sldId="256"/>
-            <ac:spMk id="5" creationId="{624D3DAE-8CE2-C218-1590-8B3F37EE9D8D}"/>
-          </ac:spMkLst>
-        </pc:spChg>
-        <pc:spChg chg="add del mod">
-          <ac:chgData name="Peter Bernhardt" userId="f2333933-0b12-4d6e-972f-f87625423892" providerId="ADAL" clId="{34DA1458-4058-4912-885C-C6A06A12728D}" dt="2026-03-23T15:45:36.362" v="2" actId="6264"/>
-          <ac:spMkLst>
-            <pc:docMk/>
-            <pc:sldMk cId="0" sldId="256"/>
-            <ac:spMk id="6" creationId="{79E0EADA-C36D-5EB1-7378-A76F59CD203F}"/>
-          </ac:spMkLst>
-        </pc:spChg>
-        <pc:spChg chg="add del mod">
-          <ac:chgData name="Peter Bernhardt" userId="f2333933-0b12-4d6e-972f-f87625423892" providerId="ADAL" clId="{34DA1458-4058-4912-885C-C6A06A12728D}" dt="2026-03-23T15:45:36.362" v="2" actId="6264"/>
-          <ac:spMkLst>
-            <pc:docMk/>
-            <pc:sldMk cId="0" sldId="256"/>
-            <ac:spMk id="7" creationId="{2C27C8C0-6E99-3D43-93E0-D6FBF1D21D6F}"/>
-          </ac:spMkLst>
-        </pc:spChg>
       </pc:sldChg>
       <pc:sldChg chg="addSp delSp modSp add mod chgLayout">
         <pc:chgData name="Peter Bernhardt" userId="f2333933-0b12-4d6e-972f-f87625423892" providerId="ADAL" clId="{34DA1458-4058-4912-885C-C6A06A12728D}" dt="2026-03-23T15:45:59.673" v="36" actId="6264"/>
@@ -1435,14 +1409,6 @@
             <pc:docMk/>
             <pc:sldMk cId="0" sldId="257"/>
             <ac:spMk id="2" creationId="{00000000-0000-0000-0000-000000000000}"/>
-          </ac:spMkLst>
-        </pc:spChg>
-        <pc:spChg chg="add del mod">
-          <ac:chgData name="Peter Bernhardt" userId="f2333933-0b12-4d6e-972f-f87625423892" providerId="ADAL" clId="{34DA1458-4058-4912-885C-C6A06A12728D}" dt="2026-03-23T15:45:59.673" v="36" actId="6264"/>
-          <ac:spMkLst>
-            <pc:docMk/>
-            <pc:sldMk cId="0" sldId="257"/>
-            <ac:spMk id="3" creationId="{2459CFCD-647C-0E37-FF3A-936EF05642DF}"/>
           </ac:spMkLst>
         </pc:spChg>
         <pc:spChg chg="add mod ord">
@@ -1474,22 +1440,6 @@
             <pc:docMk/>
             <pc:sldMk cId="0" sldId="258"/>
             <ac:spMk id="3" creationId="{00000000-0000-0000-0000-000000000000}"/>
-          </ac:spMkLst>
-        </pc:spChg>
-        <pc:spChg chg="add del mod">
-          <ac:chgData name="Peter Bernhardt" userId="f2333933-0b12-4d6e-972f-f87625423892" providerId="ADAL" clId="{34DA1458-4058-4912-885C-C6A06A12728D}" dt="2026-03-23T15:46:12.382" v="38" actId="6264"/>
-          <ac:spMkLst>
-            <pc:docMk/>
-            <pc:sldMk cId="0" sldId="258"/>
-            <ac:spMk id="4" creationId="{8CE6E205-D499-4B71-F72B-CE1C212853BB}"/>
-          </ac:spMkLst>
-        </pc:spChg>
-        <pc:spChg chg="add del mod">
-          <ac:chgData name="Peter Bernhardt" userId="f2333933-0b12-4d6e-972f-f87625423892" providerId="ADAL" clId="{34DA1458-4058-4912-885C-C6A06A12728D}" dt="2026-03-23T15:46:12.382" v="38" actId="6264"/>
-          <ac:spMkLst>
-            <pc:docMk/>
-            <pc:sldMk cId="0" sldId="258"/>
-            <ac:spMk id="5" creationId="{C636CB44-86C4-49FC-DE4A-1723E65F32B3}"/>
           </ac:spMkLst>
         </pc:spChg>
       </pc:sldChg>
@@ -1543,14 +1493,6 @@
             <ac:spMk id="2" creationId="{00000000-0000-0000-0000-000000000000}"/>
           </ac:spMkLst>
         </pc:spChg>
-        <pc:spChg chg="add del mod">
-          <ac:chgData name="Peter Bernhardt" userId="f2333933-0b12-4d6e-972f-f87625423892" providerId="ADAL" clId="{34DA1458-4058-4912-885C-C6A06A12728D}" dt="2026-03-23T15:46:25.834" v="39" actId="6264"/>
-          <ac:spMkLst>
-            <pc:docMk/>
-            <pc:sldMk cId="0" sldId="263"/>
-            <ac:spMk id="3" creationId="{0389FF37-5B64-0F5C-651E-8583111B84D6}"/>
-          </ac:spMkLst>
-        </pc:spChg>
         <pc:spChg chg="add mod ord">
           <ac:chgData name="Peter Bernhardt" userId="f2333933-0b12-4d6e-972f-f87625423892" providerId="ADAL" clId="{34DA1458-4058-4912-885C-C6A06A12728D}" dt="2026-03-23T15:46:25.834" v="39" actId="6264"/>
           <ac:spMkLst>
@@ -1574,13 +1516,6 @@
             <ac:spMk id="3" creationId="{00000000-0000-0000-0000-000000000000}"/>
           </ac:spMkLst>
         </pc:spChg>
-      </pc:sldChg>
-      <pc:sldChg chg="add del">
-        <pc:chgData name="Peter Bernhardt" userId="f2333933-0b12-4d6e-972f-f87625423892" providerId="ADAL" clId="{34DA1458-4058-4912-885C-C6A06A12728D}" dt="2026-03-23T15:50:20.336" v="75" actId="47"/>
-        <pc:sldMkLst>
-          <pc:docMk/>
-          <pc:sldMk cId="0" sldId="265"/>
-        </pc:sldMkLst>
       </pc:sldChg>
       <pc:sldChg chg="modSp add mod">
         <pc:chgData name="Peter Bernhardt" userId="f2333933-0b12-4d6e-972f-f87625423892" providerId="ADAL" clId="{34DA1458-4058-4912-885C-C6A06A12728D}" dt="2026-03-23T15:50:30.653" v="76" actId="12"/>
@@ -1678,14 +1613,6 @@
             <ac:spMk id="2" creationId="{00000000-0000-0000-0000-000000000000}"/>
           </ac:spMkLst>
         </pc:spChg>
-        <pc:spChg chg="add del mod">
-          <ac:chgData name="Peter Bernhardt" userId="f2333933-0b12-4d6e-972f-f87625423892" providerId="ADAL" clId="{34DA1458-4058-4912-885C-C6A06A12728D}" dt="2026-03-23T15:46:49.145" v="40" actId="6264"/>
-          <ac:spMkLst>
-            <pc:docMk/>
-            <pc:sldMk cId="0" sldId="272"/>
-            <ac:spMk id="3" creationId="{7E946998-6C48-255C-8E09-453218F4A962}"/>
-          </ac:spMkLst>
-        </pc:spChg>
         <pc:spChg chg="add mod ord">
           <ac:chgData name="Peter Bernhardt" userId="f2333933-0b12-4d6e-972f-f87625423892" providerId="ADAL" clId="{34DA1458-4058-4912-885C-C6A06A12728D}" dt="2026-03-23T15:46:49.145" v="40" actId="6264"/>
           <ac:spMkLst>
@@ -1710,12 +1637,20 @@
           </ac:spMkLst>
         </pc:spChg>
       </pc:sldChg>
-      <pc:sldChg chg="add">
-        <pc:chgData name="Peter Bernhardt" userId="f2333933-0b12-4d6e-972f-f87625423892" providerId="ADAL" clId="{34DA1458-4058-4912-885C-C6A06A12728D}" dt="2026-03-23T15:44:58.832" v="0"/>
+      <pc:sldChg chg="modSp add mod">
+        <pc:chgData name="Peter Bernhardt" userId="f2333933-0b12-4d6e-972f-f87625423892" providerId="ADAL" clId="{34DA1458-4058-4912-885C-C6A06A12728D}" dt="2026-03-26T14:45:12.464" v="720" actId="6549"/>
         <pc:sldMkLst>
           <pc:docMk/>
           <pc:sldMk cId="0" sldId="274"/>
         </pc:sldMkLst>
+        <pc:spChg chg="mod">
+          <ac:chgData name="Peter Bernhardt" userId="f2333933-0b12-4d6e-972f-f87625423892" providerId="ADAL" clId="{34DA1458-4058-4912-885C-C6A06A12728D}" dt="2026-03-26T14:45:12.464" v="720" actId="6549"/>
+          <ac:spMkLst>
+            <pc:docMk/>
+            <pc:sldMk cId="0" sldId="274"/>
+            <ac:spMk id="3" creationId="{00000000-0000-0000-0000-000000000000}"/>
+          </ac:spMkLst>
+        </pc:spChg>
       </pc:sldChg>
       <pc:sldChg chg="modSp add mod">
         <pc:chgData name="Peter Bernhardt" userId="f2333933-0b12-4d6e-972f-f87625423892" providerId="ADAL" clId="{34DA1458-4058-4912-885C-C6A06A12728D}" dt="2026-03-23T15:55:09.980" v="112" actId="20577"/>
@@ -1815,13 +1750,6 @@
           </ac:spMkLst>
         </pc:spChg>
       </pc:sldChg>
-      <pc:sldChg chg="add del">
-        <pc:chgData name="Peter Bernhardt" userId="f2333933-0b12-4d6e-972f-f87625423892" providerId="ADAL" clId="{34DA1458-4058-4912-885C-C6A06A12728D}" dt="2026-03-23T15:58:06.659" v="188" actId="47"/>
-        <pc:sldMkLst>
-          <pc:docMk/>
-          <pc:sldMk cId="0" sldId="281"/>
-        </pc:sldMkLst>
-      </pc:sldChg>
       <pc:sldChg chg="modSp add mod">
         <pc:chgData name="Peter Bernhardt" userId="f2333933-0b12-4d6e-972f-f87625423892" providerId="ADAL" clId="{34DA1458-4058-4912-885C-C6A06A12728D}" dt="2026-03-23T15:59:04.673" v="212" actId="20577"/>
         <pc:sldMkLst>
@@ -1896,14 +1824,6 @@
             <ac:spMk id="2" creationId="{00000000-0000-0000-0000-000000000000}"/>
           </ac:spMkLst>
         </pc:spChg>
-        <pc:spChg chg="add del mod">
-          <ac:chgData name="Peter Bernhardt" userId="f2333933-0b12-4d6e-972f-f87625423892" providerId="ADAL" clId="{34DA1458-4058-4912-885C-C6A06A12728D}" dt="2026-03-23T15:47:27.716" v="43" actId="6264"/>
-          <ac:spMkLst>
-            <pc:docMk/>
-            <pc:sldMk cId="0" sldId="286"/>
-            <ac:spMk id="3" creationId="{20890968-8EB3-A5BE-3021-E6298AEF5D71}"/>
-          </ac:spMkLst>
-        </pc:spChg>
         <pc:spChg chg="add mod ord">
           <ac:chgData name="Peter Bernhardt" userId="f2333933-0b12-4d6e-972f-f87625423892" providerId="ADAL" clId="{34DA1458-4058-4912-885C-C6A06A12728D}" dt="2026-03-23T15:47:27.716" v="43" actId="6264"/>
           <ac:spMkLst>
@@ -1939,21 +1859,6 @@
           <ac:spMkLst>
             <pc:docMk/>
             <pc:sldMk cId="0" sldId="288"/>
-            <ac:spMk id="3" creationId="{00000000-0000-0000-0000-000000000000}"/>
-          </ac:spMkLst>
-        </pc:spChg>
-      </pc:sldChg>
-      <pc:sldChg chg="modSp add del mod">
-        <pc:chgData name="Peter Bernhardt" userId="f2333933-0b12-4d6e-972f-f87625423892" providerId="ADAL" clId="{34DA1458-4058-4912-885C-C6A06A12728D}" dt="2026-03-23T16:02:34.871" v="270" actId="47"/>
-        <pc:sldMkLst>
-          <pc:docMk/>
-          <pc:sldMk cId="0" sldId="289"/>
-        </pc:sldMkLst>
-        <pc:spChg chg="mod">
-          <ac:chgData name="Peter Bernhardt" userId="f2333933-0b12-4d6e-972f-f87625423892" providerId="ADAL" clId="{34DA1458-4058-4912-885C-C6A06A12728D}" dt="2026-03-23T16:01:33.398" v="251" actId="20577"/>
-          <ac:spMkLst>
-            <pc:docMk/>
-            <pc:sldMk cId="0" sldId="289"/>
             <ac:spMk id="3" creationId="{00000000-0000-0000-0000-000000000000}"/>
           </ac:spMkLst>
         </pc:spChg>
@@ -2037,14 +1942,6 @@
             <pc:docMk/>
             <pc:sldMk cId="0" sldId="295"/>
             <ac:spMk id="2" creationId="{00000000-0000-0000-0000-000000000000}"/>
-          </ac:spMkLst>
-        </pc:spChg>
-        <pc:spChg chg="add del mod">
-          <ac:chgData name="Peter Bernhardt" userId="f2333933-0b12-4d6e-972f-f87625423892" providerId="ADAL" clId="{34DA1458-4058-4912-885C-C6A06A12728D}" dt="2026-03-23T15:47:43.309" v="44" actId="6264"/>
-          <ac:spMkLst>
-            <pc:docMk/>
-            <pc:sldMk cId="0" sldId="295"/>
-            <ac:spMk id="3" creationId="{27538919-EE44-119C-A865-CD31AD824647}"/>
           </ac:spMkLst>
         </pc:spChg>
         <pc:spChg chg="add mod ord">
@@ -2259,14 +2156,6 @@
             <ac:spMk id="2" creationId="{00000000-0000-0000-0000-000000000000}"/>
           </ac:spMkLst>
         </pc:spChg>
-        <pc:spChg chg="add del mod">
-          <ac:chgData name="Peter Bernhardt" userId="f2333933-0b12-4d6e-972f-f87625423892" providerId="ADAL" clId="{34DA1458-4058-4912-885C-C6A06A12728D}" dt="2026-03-23T15:48:00.223" v="45" actId="6264"/>
-          <ac:spMkLst>
-            <pc:docMk/>
-            <pc:sldMk cId="0" sldId="307"/>
-            <ac:spMk id="3" creationId="{16B49865-1B3D-2964-133E-3263D1477367}"/>
-          </ac:spMkLst>
-        </pc:spChg>
         <pc:spChg chg="add mod ord">
           <ac:chgData name="Peter Bernhardt" userId="f2333933-0b12-4d6e-972f-f87625423892" providerId="ADAL" clId="{34DA1458-4058-4912-885C-C6A06A12728D}" dt="2026-03-23T15:48:00.223" v="45" actId="6264"/>
           <ac:spMkLst>
@@ -2313,22 +2202,6 @@
             <ac:spMk id="3" creationId="{00000000-0000-0000-0000-000000000000}"/>
           </ac:spMkLst>
         </pc:spChg>
-        <pc:spChg chg="add del mod">
-          <ac:chgData name="Peter Bernhardt" userId="f2333933-0b12-4d6e-972f-f87625423892" providerId="ADAL" clId="{34DA1458-4058-4912-885C-C6A06A12728D}" dt="2026-03-23T15:48:09.668" v="47" actId="6264"/>
-          <ac:spMkLst>
-            <pc:docMk/>
-            <pc:sldMk cId="0" sldId="309"/>
-            <ac:spMk id="4" creationId="{6B177639-A092-7C58-CAF4-8F3778E12778}"/>
-          </ac:spMkLst>
-        </pc:spChg>
-        <pc:spChg chg="add del mod">
-          <ac:chgData name="Peter Bernhardt" userId="f2333933-0b12-4d6e-972f-f87625423892" providerId="ADAL" clId="{34DA1458-4058-4912-885C-C6A06A12728D}" dt="2026-03-23T15:48:09.668" v="47" actId="6264"/>
-          <ac:spMkLst>
-            <pc:docMk/>
-            <pc:sldMk cId="0" sldId="309"/>
-            <ac:spMk id="5" creationId="{602932FE-ABF9-8456-6F43-0905FF9E2057}"/>
-          </ac:spMkLst>
-        </pc:spChg>
       </pc:sldChg>
       <pc:sldChg chg="modSp add mod">
         <pc:chgData name="Peter Bernhardt" userId="f2333933-0b12-4d6e-972f-f87625423892" providerId="ADAL" clId="{34DA1458-4058-4912-885C-C6A06A12728D}" dt="2026-03-23T15:59:40.694" v="234" actId="20577"/>
@@ -2353,247 +2226,323 @@
           </ac:spMkLst>
         </pc:spChg>
       </pc:sldChg>
-      <pc:sldChg chg="del">
-        <pc:chgData name="Peter Bernhardt" userId="f2333933-0b12-4d6e-972f-f87625423892" providerId="ADAL" clId="{34DA1458-4058-4912-885C-C6A06A12728D}" dt="2026-03-23T15:48:38.961" v="49" actId="47"/>
-        <pc:sldMkLst>
-          <pc:docMk/>
-          <pc:sldMk cId="0" sldId="312"/>
-        </pc:sldMkLst>
-      </pc:sldChg>
-      <pc:sldChg chg="del">
-        <pc:chgData name="Peter Bernhardt" userId="f2333933-0b12-4d6e-972f-f87625423892" providerId="ADAL" clId="{34DA1458-4058-4912-885C-C6A06A12728D}" dt="2026-03-23T15:45:17.014" v="1" actId="47"/>
-        <pc:sldMkLst>
-          <pc:docMk/>
-          <pc:sldMk cId="0" sldId="313"/>
-        </pc:sldMkLst>
-      </pc:sldChg>
-      <pc:sldChg chg="del">
-        <pc:chgData name="Peter Bernhardt" userId="f2333933-0b12-4d6e-972f-f87625423892" providerId="ADAL" clId="{34DA1458-4058-4912-885C-C6A06A12728D}" dt="2026-03-23T15:45:17.014" v="1" actId="47"/>
-        <pc:sldMkLst>
-          <pc:docMk/>
-          <pc:sldMk cId="0" sldId="314"/>
-        </pc:sldMkLst>
-      </pc:sldChg>
-      <pc:sldChg chg="del">
-        <pc:chgData name="Peter Bernhardt" userId="f2333933-0b12-4d6e-972f-f87625423892" providerId="ADAL" clId="{34DA1458-4058-4912-885C-C6A06A12728D}" dt="2026-03-23T15:45:17.014" v="1" actId="47"/>
-        <pc:sldMkLst>
-          <pc:docMk/>
-          <pc:sldMk cId="0" sldId="315"/>
-        </pc:sldMkLst>
-      </pc:sldChg>
-      <pc:sldChg chg="del">
-        <pc:chgData name="Peter Bernhardt" userId="f2333933-0b12-4d6e-972f-f87625423892" providerId="ADAL" clId="{34DA1458-4058-4912-885C-C6A06A12728D}" dt="2026-03-23T15:45:17.014" v="1" actId="47"/>
-        <pc:sldMkLst>
-          <pc:docMk/>
-          <pc:sldMk cId="0" sldId="316"/>
-        </pc:sldMkLst>
-      </pc:sldChg>
-      <pc:sldChg chg="del">
-        <pc:chgData name="Peter Bernhardt" userId="f2333933-0b12-4d6e-972f-f87625423892" providerId="ADAL" clId="{34DA1458-4058-4912-885C-C6A06A12728D}" dt="2026-03-23T15:45:17.014" v="1" actId="47"/>
-        <pc:sldMkLst>
-          <pc:docMk/>
-          <pc:sldMk cId="0" sldId="317"/>
-        </pc:sldMkLst>
-      </pc:sldChg>
-      <pc:sldChg chg="del">
-        <pc:chgData name="Peter Bernhardt" userId="f2333933-0b12-4d6e-972f-f87625423892" providerId="ADAL" clId="{34DA1458-4058-4912-885C-C6A06A12728D}" dt="2026-03-23T15:45:17.014" v="1" actId="47"/>
-        <pc:sldMkLst>
-          <pc:docMk/>
-          <pc:sldMk cId="0" sldId="318"/>
-        </pc:sldMkLst>
-      </pc:sldChg>
-      <pc:sldChg chg="del">
-        <pc:chgData name="Peter Bernhardt" userId="f2333933-0b12-4d6e-972f-f87625423892" providerId="ADAL" clId="{34DA1458-4058-4912-885C-C6A06A12728D}" dt="2026-03-23T15:45:17.014" v="1" actId="47"/>
-        <pc:sldMkLst>
-          <pc:docMk/>
-          <pc:sldMk cId="0" sldId="319"/>
-        </pc:sldMkLst>
-      </pc:sldChg>
-      <pc:sldChg chg="del">
-        <pc:chgData name="Peter Bernhardt" userId="f2333933-0b12-4d6e-972f-f87625423892" providerId="ADAL" clId="{34DA1458-4058-4912-885C-C6A06A12728D}" dt="2026-03-23T15:45:17.014" v="1" actId="47"/>
-        <pc:sldMkLst>
-          <pc:docMk/>
-          <pc:sldMk cId="0" sldId="320"/>
-        </pc:sldMkLst>
-      </pc:sldChg>
-      <pc:sldChg chg="del">
-        <pc:chgData name="Peter Bernhardt" userId="f2333933-0b12-4d6e-972f-f87625423892" providerId="ADAL" clId="{34DA1458-4058-4912-885C-C6A06A12728D}" dt="2026-03-23T15:45:17.014" v="1" actId="47"/>
-        <pc:sldMkLst>
-          <pc:docMk/>
-          <pc:sldMk cId="0" sldId="321"/>
-        </pc:sldMkLst>
-      </pc:sldChg>
-      <pc:sldChg chg="del">
-        <pc:chgData name="Peter Bernhardt" userId="f2333933-0b12-4d6e-972f-f87625423892" providerId="ADAL" clId="{34DA1458-4058-4912-885C-C6A06A12728D}" dt="2026-03-23T15:45:17.014" v="1" actId="47"/>
-        <pc:sldMkLst>
-          <pc:docMk/>
-          <pc:sldMk cId="0" sldId="322"/>
-        </pc:sldMkLst>
-      </pc:sldChg>
-      <pc:sldChg chg="del">
-        <pc:chgData name="Peter Bernhardt" userId="f2333933-0b12-4d6e-972f-f87625423892" providerId="ADAL" clId="{34DA1458-4058-4912-885C-C6A06A12728D}" dt="2026-03-23T15:45:17.014" v="1" actId="47"/>
-        <pc:sldMkLst>
-          <pc:docMk/>
-          <pc:sldMk cId="0" sldId="323"/>
-        </pc:sldMkLst>
-      </pc:sldChg>
-      <pc:sldChg chg="del">
-        <pc:chgData name="Peter Bernhardt" userId="f2333933-0b12-4d6e-972f-f87625423892" providerId="ADAL" clId="{34DA1458-4058-4912-885C-C6A06A12728D}" dt="2026-03-23T15:45:17.014" v="1" actId="47"/>
-        <pc:sldMkLst>
-          <pc:docMk/>
-          <pc:sldMk cId="0" sldId="324"/>
-        </pc:sldMkLst>
-      </pc:sldChg>
-      <pc:sldChg chg="del">
-        <pc:chgData name="Peter Bernhardt" userId="f2333933-0b12-4d6e-972f-f87625423892" providerId="ADAL" clId="{34DA1458-4058-4912-885C-C6A06A12728D}" dt="2026-03-23T15:45:17.014" v="1" actId="47"/>
-        <pc:sldMkLst>
-          <pc:docMk/>
-          <pc:sldMk cId="0" sldId="325"/>
-        </pc:sldMkLst>
-      </pc:sldChg>
-      <pc:sldChg chg="del">
-        <pc:chgData name="Peter Bernhardt" userId="f2333933-0b12-4d6e-972f-f87625423892" providerId="ADAL" clId="{34DA1458-4058-4912-885C-C6A06A12728D}" dt="2026-03-23T15:45:17.014" v="1" actId="47"/>
-        <pc:sldMkLst>
-          <pc:docMk/>
-          <pc:sldMk cId="0" sldId="326"/>
-        </pc:sldMkLst>
-      </pc:sldChg>
-      <pc:sldChg chg="del">
-        <pc:chgData name="Peter Bernhardt" userId="f2333933-0b12-4d6e-972f-f87625423892" providerId="ADAL" clId="{34DA1458-4058-4912-885C-C6A06A12728D}" dt="2026-03-23T15:45:17.014" v="1" actId="47"/>
-        <pc:sldMkLst>
-          <pc:docMk/>
-          <pc:sldMk cId="0" sldId="327"/>
-        </pc:sldMkLst>
-      </pc:sldChg>
-      <pc:sldChg chg="del">
-        <pc:chgData name="Peter Bernhardt" userId="f2333933-0b12-4d6e-972f-f87625423892" providerId="ADAL" clId="{34DA1458-4058-4912-885C-C6A06A12728D}" dt="2026-03-23T15:45:17.014" v="1" actId="47"/>
-        <pc:sldMkLst>
-          <pc:docMk/>
-          <pc:sldMk cId="0" sldId="328"/>
-        </pc:sldMkLst>
-      </pc:sldChg>
-      <pc:sldChg chg="del">
-        <pc:chgData name="Peter Bernhardt" userId="f2333933-0b12-4d6e-972f-f87625423892" providerId="ADAL" clId="{34DA1458-4058-4912-885C-C6A06A12728D}" dt="2026-03-23T15:45:17.014" v="1" actId="47"/>
-        <pc:sldMkLst>
-          <pc:docMk/>
-          <pc:sldMk cId="0" sldId="329"/>
-        </pc:sldMkLst>
-      </pc:sldChg>
-      <pc:sldChg chg="del">
-        <pc:chgData name="Peter Bernhardt" userId="f2333933-0b12-4d6e-972f-f87625423892" providerId="ADAL" clId="{34DA1458-4058-4912-885C-C6A06A12728D}" dt="2026-03-23T15:45:17.014" v="1" actId="47"/>
-        <pc:sldMkLst>
-          <pc:docMk/>
-          <pc:sldMk cId="0" sldId="330"/>
-        </pc:sldMkLst>
-      </pc:sldChg>
-      <pc:sldChg chg="del">
-        <pc:chgData name="Peter Bernhardt" userId="f2333933-0b12-4d6e-972f-f87625423892" providerId="ADAL" clId="{34DA1458-4058-4912-885C-C6A06A12728D}" dt="2026-03-23T15:45:17.014" v="1" actId="47"/>
-        <pc:sldMkLst>
-          <pc:docMk/>
-          <pc:sldMk cId="0" sldId="331"/>
-        </pc:sldMkLst>
-      </pc:sldChg>
-      <pc:sldChg chg="del">
-        <pc:chgData name="Peter Bernhardt" userId="f2333933-0b12-4d6e-972f-f87625423892" providerId="ADAL" clId="{34DA1458-4058-4912-885C-C6A06A12728D}" dt="2026-03-23T15:45:17.014" v="1" actId="47"/>
-        <pc:sldMkLst>
-          <pc:docMk/>
-          <pc:sldMk cId="0" sldId="332"/>
-        </pc:sldMkLst>
-      </pc:sldChg>
-      <pc:sldChg chg="del">
-        <pc:chgData name="Peter Bernhardt" userId="f2333933-0b12-4d6e-972f-f87625423892" providerId="ADAL" clId="{34DA1458-4058-4912-885C-C6A06A12728D}" dt="2026-03-23T15:45:17.014" v="1" actId="47"/>
-        <pc:sldMkLst>
-          <pc:docMk/>
-          <pc:sldMk cId="0" sldId="333"/>
-        </pc:sldMkLst>
-      </pc:sldChg>
-      <pc:sldChg chg="del">
-        <pc:chgData name="Peter Bernhardt" userId="f2333933-0b12-4d6e-972f-f87625423892" providerId="ADAL" clId="{34DA1458-4058-4912-885C-C6A06A12728D}" dt="2026-03-23T15:45:17.014" v="1" actId="47"/>
-        <pc:sldMkLst>
-          <pc:docMk/>
-          <pc:sldMk cId="0" sldId="334"/>
-        </pc:sldMkLst>
-      </pc:sldChg>
-      <pc:sldChg chg="del">
-        <pc:chgData name="Peter Bernhardt" userId="f2333933-0b12-4d6e-972f-f87625423892" providerId="ADAL" clId="{34DA1458-4058-4912-885C-C6A06A12728D}" dt="2026-03-23T15:45:17.014" v="1" actId="47"/>
-        <pc:sldMkLst>
-          <pc:docMk/>
-          <pc:sldMk cId="0" sldId="335"/>
-        </pc:sldMkLst>
-      </pc:sldChg>
-      <pc:sldChg chg="del">
-        <pc:chgData name="Peter Bernhardt" userId="f2333933-0b12-4d6e-972f-f87625423892" providerId="ADAL" clId="{34DA1458-4058-4912-885C-C6A06A12728D}" dt="2026-03-23T15:45:17.014" v="1" actId="47"/>
-        <pc:sldMkLst>
-          <pc:docMk/>
-          <pc:sldMk cId="0" sldId="336"/>
-        </pc:sldMkLst>
-      </pc:sldChg>
-      <pc:sldChg chg="del">
-        <pc:chgData name="Peter Bernhardt" userId="f2333933-0b12-4d6e-972f-f87625423892" providerId="ADAL" clId="{34DA1458-4058-4912-885C-C6A06A12728D}" dt="2026-03-23T15:45:17.014" v="1" actId="47"/>
-        <pc:sldMkLst>
-          <pc:docMk/>
-          <pc:sldMk cId="0" sldId="337"/>
-        </pc:sldMkLst>
-      </pc:sldChg>
-      <pc:sldChg chg="del">
-        <pc:chgData name="Peter Bernhardt" userId="f2333933-0b12-4d6e-972f-f87625423892" providerId="ADAL" clId="{34DA1458-4058-4912-885C-C6A06A12728D}" dt="2026-03-23T15:45:17.014" v="1" actId="47"/>
-        <pc:sldMkLst>
-          <pc:docMk/>
-          <pc:sldMk cId="0" sldId="338"/>
-        </pc:sldMkLst>
-      </pc:sldChg>
-      <pc:sldChg chg="del">
-        <pc:chgData name="Peter Bernhardt" userId="f2333933-0b12-4d6e-972f-f87625423892" providerId="ADAL" clId="{34DA1458-4058-4912-885C-C6A06A12728D}" dt="2026-03-23T15:45:17.014" v="1" actId="47"/>
-        <pc:sldMkLst>
-          <pc:docMk/>
-          <pc:sldMk cId="0" sldId="339"/>
-        </pc:sldMkLst>
-      </pc:sldChg>
-      <pc:sldChg chg="del">
-        <pc:chgData name="Peter Bernhardt" userId="f2333933-0b12-4d6e-972f-f87625423892" providerId="ADAL" clId="{34DA1458-4058-4912-885C-C6A06A12728D}" dt="2026-03-23T15:45:17.014" v="1" actId="47"/>
-        <pc:sldMkLst>
-          <pc:docMk/>
-          <pc:sldMk cId="0" sldId="340"/>
-        </pc:sldMkLst>
-      </pc:sldChg>
-      <pc:sldChg chg="del">
-        <pc:chgData name="Peter Bernhardt" userId="f2333933-0b12-4d6e-972f-f87625423892" providerId="ADAL" clId="{34DA1458-4058-4912-885C-C6A06A12728D}" dt="2026-03-23T15:45:17.014" v="1" actId="47"/>
-        <pc:sldMkLst>
-          <pc:docMk/>
-          <pc:sldMk cId="0" sldId="341"/>
-        </pc:sldMkLst>
-      </pc:sldChg>
-      <pc:sldChg chg="del">
-        <pc:chgData name="Peter Bernhardt" userId="f2333933-0b12-4d6e-972f-f87625423892" providerId="ADAL" clId="{34DA1458-4058-4912-885C-C6A06A12728D}" dt="2026-03-23T15:45:17.014" v="1" actId="47"/>
-        <pc:sldMkLst>
-          <pc:docMk/>
-          <pc:sldMk cId="0" sldId="342"/>
-        </pc:sldMkLst>
-      </pc:sldChg>
-      <pc:sldChg chg="del">
-        <pc:chgData name="Peter Bernhardt" userId="f2333933-0b12-4d6e-972f-f87625423892" providerId="ADAL" clId="{34DA1458-4058-4912-885C-C6A06A12728D}" dt="2026-03-23T15:45:17.014" v="1" actId="47"/>
-        <pc:sldMkLst>
-          <pc:docMk/>
-          <pc:sldMk cId="0" sldId="343"/>
-        </pc:sldMkLst>
-      </pc:sldChg>
-      <pc:sldChg chg="del">
-        <pc:chgData name="Peter Bernhardt" userId="f2333933-0b12-4d6e-972f-f87625423892" providerId="ADAL" clId="{34DA1458-4058-4912-885C-C6A06A12728D}" dt="2026-03-23T15:45:17.014" v="1" actId="47"/>
-        <pc:sldMkLst>
-          <pc:docMk/>
-          <pc:sldMk cId="0" sldId="344"/>
-        </pc:sldMkLst>
-      </pc:sldChg>
-      <pc:sldChg chg="del">
-        <pc:chgData name="Peter Bernhardt" userId="f2333933-0b12-4d6e-972f-f87625423892" providerId="ADAL" clId="{34DA1458-4058-4912-885C-C6A06A12728D}" dt="2026-03-23T15:45:17.014" v="1" actId="47"/>
-        <pc:sldMkLst>
-          <pc:docMk/>
-          <pc:sldMk cId="0" sldId="345"/>
-        </pc:sldMkLst>
-      </pc:sldChg>
     </pc:docChg>
   </pc:docChgLst>
 </pc:chgInfo>
+</file>
+
+<file path=ppt/notesMasters/notesMaster1.xml><?xml version="1.0" encoding="utf-8"?>
+<p:notesMaster xmlns:a="http://schemas.openxmlformats.org/drawingml/2006/main" xmlns:r="http://schemas.openxmlformats.org/officeDocument/2006/relationships" xmlns:p="http://schemas.openxmlformats.org/presentationml/2006/main">
+  <p:cSld>
+    <p:bg>
+      <p:bgRef idx="1001">
+        <a:schemeClr val="bg1"/>
+      </p:bgRef>
+    </p:bg>
+    <p:spTree>
+      <p:nvGrpSpPr>
+        <p:cNvPr id="1" name=""/>
+        <p:cNvGrpSpPr/>
+        <p:nvPr/>
+      </p:nvGrpSpPr>
+      <p:grpSpPr>
+        <a:xfrm>
+          <a:off x="0" y="0"/>
+          <a:ext cx="0" cy="0"/>
+          <a:chOff x="0" y="0"/>
+          <a:chExt cx="0" cy="0"/>
+        </a:xfrm>
+      </p:grpSpPr>
+      <p:sp>
+        <p:nvSpPr>
+          <p:cNvPr id="2" name="Kopfzeilenplatzhalter 1"/>
+          <p:cNvSpPr>
+            <a:spLocks noGrp="1"/>
+          </p:cNvSpPr>
+          <p:nvPr>
+            <p:ph type="hdr" sz="quarter"/>
+          </p:nvPr>
+        </p:nvSpPr>
+        <p:spPr>
+          <a:xfrm>
+            <a:off x="0" y="0"/>
+            <a:ext cx="2971800" cy="458788"/>
+          </a:xfrm>
+          <a:prstGeom prst="rect">
+            <a:avLst/>
+          </a:prstGeom>
+        </p:spPr>
+        <p:txBody>
+          <a:bodyPr vert="horz" lIns="91440" tIns="45720" rIns="91440" bIns="45720" rtlCol="0"/>
+          <a:lstStyle>
+            <a:lvl1pPr algn="l">
+              <a:defRPr sz="1200"/>
+            </a:lvl1pPr>
+          </a:lstStyle>
+          <a:p>
+            <a:endParaRPr lang="de-DE"/>
+          </a:p>
+        </p:txBody>
+      </p:sp>
+      <p:sp>
+        <p:nvSpPr>
+          <p:cNvPr id="4" name="Folienbildplatzhalter 3"/>
+          <p:cNvSpPr>
+            <a:spLocks noGrp="1" noRot="1" noChangeAspect="1"/>
+          </p:cNvSpPr>
+          <p:nvPr>
+            <p:ph type="sldImg" idx="2"/>
+          </p:nvPr>
+        </p:nvSpPr>
+        <p:spPr>
+          <a:xfrm>
+            <a:off x="1371600" y="1143000"/>
+            <a:ext cx="4114800" cy="3086100"/>
+          </a:xfrm>
+          <a:prstGeom prst="rect">
+            <a:avLst/>
+          </a:prstGeom>
+          <a:noFill/>
+          <a:ln w="12700">
+            <a:solidFill>
+              <a:prstClr val="black"/>
+            </a:solidFill>
+          </a:ln>
+        </p:spPr>
+        <p:txBody>
+          <a:bodyPr vert="horz" lIns="91440" tIns="45720" rIns="91440" bIns="45720" rtlCol="0" anchor="ctr"/>
+          <a:lstStyle/>
+          <a:p>
+            <a:endParaRPr lang="de-DE"/>
+          </a:p>
+        </p:txBody>
+      </p:sp>
+      <p:sp>
+        <p:nvSpPr>
+          <p:cNvPr id="5" name="Notizenplatzhalter 4"/>
+          <p:cNvSpPr>
+            <a:spLocks noGrp="1"/>
+          </p:cNvSpPr>
+          <p:nvPr>
+            <p:ph type="body" sz="quarter" idx="3"/>
+          </p:nvPr>
+        </p:nvSpPr>
+        <p:spPr>
+          <a:xfrm>
+            <a:off x="685800" y="4400550"/>
+            <a:ext cx="5486400" cy="3600450"/>
+          </a:xfrm>
+          <a:prstGeom prst="rect">
+            <a:avLst/>
+          </a:prstGeom>
+        </p:spPr>
+        <p:txBody>
+          <a:bodyPr vert="horz" lIns="91440" tIns="45720" rIns="91440" bIns="45720" rtlCol="0"/>
+          <a:lstStyle/>
+          <a:p>
+            <a:pPr lvl="0"/>
+            <a:r>
+              <a:rPr lang="de-DE"/>
+              <a:t>Mastertextformat bearbeiten</a:t>
+            </a:r>
+          </a:p>
+          <a:p>
+            <a:pPr lvl="1"/>
+            <a:r>
+              <a:rPr lang="de-DE"/>
+              <a:t>Zweite Ebene</a:t>
+            </a:r>
+          </a:p>
+          <a:p>
+            <a:pPr lvl="2"/>
+            <a:r>
+              <a:rPr lang="de-DE"/>
+              <a:t>Dritte Ebene</a:t>
+            </a:r>
+          </a:p>
+          <a:p>
+            <a:pPr lvl="3"/>
+            <a:r>
+              <a:rPr lang="de-DE"/>
+              <a:t>Vierte Ebene</a:t>
+            </a:r>
+          </a:p>
+          <a:p>
+            <a:pPr lvl="4"/>
+            <a:r>
+              <a:rPr lang="de-DE"/>
+              <a:t>Fünfte Ebene</a:t>
+            </a:r>
+          </a:p>
+        </p:txBody>
+      </p:sp>
+      <p:sp>
+        <p:nvSpPr>
+          <p:cNvPr id="6" name="Fußzeilenplatzhalter 5"/>
+          <p:cNvSpPr>
+            <a:spLocks noGrp="1"/>
+          </p:cNvSpPr>
+          <p:nvPr>
+            <p:ph type="ftr" sz="quarter" idx="4"/>
+          </p:nvPr>
+        </p:nvSpPr>
+        <p:spPr>
+          <a:xfrm>
+            <a:off x="0" y="8685213"/>
+            <a:ext cx="2971800" cy="458787"/>
+          </a:xfrm>
+          <a:prstGeom prst="rect">
+            <a:avLst/>
+          </a:prstGeom>
+        </p:spPr>
+        <p:txBody>
+          <a:bodyPr vert="horz" lIns="91440" tIns="45720" rIns="91440" bIns="45720" rtlCol="0" anchor="b"/>
+          <a:lstStyle>
+            <a:lvl1pPr algn="l">
+              <a:defRPr sz="1200"/>
+            </a:lvl1pPr>
+          </a:lstStyle>
+          <a:p>
+            <a:endParaRPr lang="de-DE"/>
+          </a:p>
+        </p:txBody>
+      </p:sp>
+      <p:sp>
+        <p:nvSpPr>
+          <p:cNvPr id="7" name="Foliennummernplatzhalter 6"/>
+          <p:cNvSpPr>
+            <a:spLocks noGrp="1"/>
+          </p:cNvSpPr>
+          <p:nvPr>
+            <p:ph type="sldNum" sz="quarter" idx="5"/>
+          </p:nvPr>
+        </p:nvSpPr>
+        <p:spPr>
+          <a:xfrm>
+            <a:off x="3884613" y="8685213"/>
+            <a:ext cx="2971800" cy="458787"/>
+          </a:xfrm>
+          <a:prstGeom prst="rect">
+            <a:avLst/>
+          </a:prstGeom>
+        </p:spPr>
+        <p:txBody>
+          <a:bodyPr vert="horz" lIns="91440" tIns="45720" rIns="91440" bIns="45720" rtlCol="0" anchor="b"/>
+          <a:lstStyle>
+            <a:lvl1pPr algn="r">
+              <a:defRPr sz="1200"/>
+            </a:lvl1pPr>
+          </a:lstStyle>
+          <a:p>
+            <a:fld id="{9955F5F9-C814-4F3A-BD20-A96DD549C0F1}" type="slidenum">
+              <a:rPr lang="de-DE" smtClean="0"/>
+              <a:t>‹Nr.›</a:t>
+            </a:fld>
+            <a:endParaRPr lang="de-DE"/>
+          </a:p>
+        </p:txBody>
+      </p:sp>
+    </p:spTree>
+    <p:extLst>
+      <p:ext uri="{BB962C8B-B14F-4D97-AF65-F5344CB8AC3E}">
+        <p14:creationId xmlns:p14="http://schemas.microsoft.com/office/powerpoint/2010/main" val="1202254084"/>
+      </p:ext>
+    </p:extLst>
+  </p:cSld>
+  <p:clrMap bg1="lt1" tx1="dk1" bg2="lt2" tx2="dk2" accent1="accent1" accent2="accent2" accent3="accent3" accent4="accent4" accent5="accent5" accent6="accent6" hlink="hlink" folHlink="folHlink"/>
+  <p:notesStyle>
+    <a:lvl1pPr marL="0" algn="l" defTabSz="914400" rtl="0" eaLnBrk="1" latinLnBrk="0" hangingPunct="1">
+      <a:defRPr sz="1200" kern="1200">
+        <a:solidFill>
+          <a:schemeClr val="tx1"/>
+        </a:solidFill>
+        <a:latin typeface="+mn-lt"/>
+        <a:ea typeface="+mn-ea"/>
+        <a:cs typeface="+mn-cs"/>
+      </a:defRPr>
+    </a:lvl1pPr>
+    <a:lvl2pPr marL="457200" algn="l" defTabSz="914400" rtl="0" eaLnBrk="1" latinLnBrk="0" hangingPunct="1">
+      <a:defRPr sz="1200" kern="1200">
+        <a:solidFill>
+          <a:schemeClr val="tx1"/>
+        </a:solidFill>
+        <a:latin typeface="+mn-lt"/>
+        <a:ea typeface="+mn-ea"/>
+        <a:cs typeface="+mn-cs"/>
+      </a:defRPr>
+    </a:lvl2pPr>
+    <a:lvl3pPr marL="914400" algn="l" defTabSz="914400" rtl="0" eaLnBrk="1" latinLnBrk="0" hangingPunct="1">
+      <a:defRPr sz="1200" kern="1200">
+        <a:solidFill>
+          <a:schemeClr val="tx1"/>
+        </a:solidFill>
+        <a:latin typeface="+mn-lt"/>
+        <a:ea typeface="+mn-ea"/>
+        <a:cs typeface="+mn-cs"/>
+      </a:defRPr>
+    </a:lvl3pPr>
+    <a:lvl4pPr marL="1371600" algn="l" defTabSz="914400" rtl="0" eaLnBrk="1" latinLnBrk="0" hangingPunct="1">
+      <a:defRPr sz="1200" kern="1200">
+        <a:solidFill>
+          <a:schemeClr val="tx1"/>
+        </a:solidFill>
+        <a:latin typeface="+mn-lt"/>
+        <a:ea typeface="+mn-ea"/>
+        <a:cs typeface="+mn-cs"/>
+      </a:defRPr>
+    </a:lvl4pPr>
+    <a:lvl5pPr marL="1828800" algn="l" defTabSz="914400" rtl="0" eaLnBrk="1" latinLnBrk="0" hangingPunct="1">
+      <a:defRPr sz="1200" kern="1200">
+        <a:solidFill>
+          <a:schemeClr val="tx1"/>
+        </a:solidFill>
+        <a:latin typeface="+mn-lt"/>
+        <a:ea typeface="+mn-ea"/>
+        <a:cs typeface="+mn-cs"/>
+      </a:defRPr>
+    </a:lvl5pPr>
+    <a:lvl6pPr marL="2286000" algn="l" defTabSz="914400" rtl="0" eaLnBrk="1" latinLnBrk="0" hangingPunct="1">
+      <a:defRPr sz="1200" kern="1200">
+        <a:solidFill>
+          <a:schemeClr val="tx1"/>
+        </a:solidFill>
+        <a:latin typeface="+mn-lt"/>
+        <a:ea typeface="+mn-ea"/>
+        <a:cs typeface="+mn-cs"/>
+      </a:defRPr>
+    </a:lvl6pPr>
+    <a:lvl7pPr marL="2743200" algn="l" defTabSz="914400" rtl="0" eaLnBrk="1" latinLnBrk="0" hangingPunct="1">
+      <a:defRPr sz="1200" kern="1200">
+        <a:solidFill>
+          <a:schemeClr val="tx1"/>
+        </a:solidFill>
+        <a:latin typeface="+mn-lt"/>
+        <a:ea typeface="+mn-ea"/>
+        <a:cs typeface="+mn-cs"/>
+      </a:defRPr>
+    </a:lvl7pPr>
+    <a:lvl8pPr marL="3200400" algn="l" defTabSz="914400" rtl="0" eaLnBrk="1" latinLnBrk="0" hangingPunct="1">
+      <a:defRPr sz="1200" kern="1200">
+        <a:solidFill>
+          <a:schemeClr val="tx1"/>
+        </a:solidFill>
+        <a:latin typeface="+mn-lt"/>
+        <a:ea typeface="+mn-ea"/>
+        <a:cs typeface="+mn-cs"/>
+      </a:defRPr>
+    </a:lvl8pPr>
+    <a:lvl9pPr marL="3657600" algn="l" defTabSz="914400" rtl="0" eaLnBrk="1" latinLnBrk="0" hangingPunct="1">
+      <a:defRPr sz="1200" kern="1200">
+        <a:solidFill>
+          <a:schemeClr val="tx1"/>
+        </a:solidFill>
+        <a:latin typeface="+mn-lt"/>
+        <a:ea typeface="+mn-ea"/>
+        <a:cs typeface="+mn-cs"/>
+      </a:defRPr>
+    </a:lvl9pPr>
+  </p:notesStyle>
+</p:notesMaster>
 </file>
 
 <file path=ppt/slideLayouts/slideLayout1.xml><?xml version="1.0" encoding="utf-8"?>
@@ -2836,7 +2785,7 @@
           <a:p>
             <a:fld id="{241EB5C9-1307-BA42-ABA2-0BC069CD8E7F}" type="datetimeFigureOut">
               <a:rPr lang="en-US" smtClean="0"/>
-              <a:t>3/23/2026</a:t>
+              <a:t>3/26/2026</a:t>
             </a:fld>
             <a:endParaRPr lang="en-US"/>
           </a:p>
@@ -3044,7 +2993,7 @@
           <a:p>
             <a:fld id="{241EB5C9-1307-BA42-ABA2-0BC069CD8E7F}" type="datetimeFigureOut">
               <a:rPr lang="en-US" smtClean="0"/>
-              <a:t>3/23/2026</a:t>
+              <a:t>3/26/2026</a:t>
             </a:fld>
             <a:endParaRPr lang="en-US"/>
           </a:p>
@@ -3300,7 +3249,7 @@
           <a:p>
             <a:fld id="{241EB5C9-1307-BA42-ABA2-0BC069CD8E7F}" type="datetimeFigureOut">
               <a:rPr lang="en-US" smtClean="0"/>
-              <a:t>3/23/2026</a:t>
+              <a:t>3/26/2026</a:t>
             </a:fld>
             <a:endParaRPr lang="en-US"/>
           </a:p>
@@ -3488,7 +3437,7 @@
           <a:p>
             <a:fld id="{241EB5C9-1307-BA42-ABA2-0BC069CD8E7F}" type="datetimeFigureOut">
               <a:rPr lang="en-US" smtClean="0"/>
-              <a:t>3/23/2026</a:t>
+              <a:t>3/26/2026</a:t>
             </a:fld>
             <a:endParaRPr lang="en-US"/>
           </a:p>
@@ -3845,7 +3794,7 @@
           <a:p>
             <a:fld id="{241EB5C9-1307-BA42-ABA2-0BC069CD8E7F}" type="datetimeFigureOut">
               <a:rPr lang="en-US" smtClean="0"/>
-              <a:t>3/23/2026</a:t>
+              <a:t>3/26/2026</a:t>
             </a:fld>
             <a:endParaRPr lang="en-US"/>
           </a:p>
@@ -4120,7 +4069,7 @@
           <a:p>
             <a:fld id="{241EB5C9-1307-BA42-ABA2-0BC069CD8E7F}" type="datetimeFigureOut">
               <a:rPr lang="en-US" smtClean="0"/>
-              <a:t>3/23/2026</a:t>
+              <a:t>3/26/2026</a:t>
             </a:fld>
             <a:endParaRPr lang="en-US"/>
           </a:p>
@@ -4499,7 +4448,7 @@
           <a:p>
             <a:fld id="{241EB5C9-1307-BA42-ABA2-0BC069CD8E7F}" type="datetimeFigureOut">
               <a:rPr lang="en-US" smtClean="0"/>
-              <a:t>3/23/2026</a:t>
+              <a:t>3/26/2026</a:t>
             </a:fld>
             <a:endParaRPr lang="en-US"/>
           </a:p>
@@ -4617,7 +4566,7 @@
           <a:p>
             <a:fld id="{241EB5C9-1307-BA42-ABA2-0BC069CD8E7F}" type="datetimeFigureOut">
               <a:rPr lang="en-US" smtClean="0"/>
-              <a:t>3/23/2026</a:t>
+              <a:t>3/26/2026</a:t>
             </a:fld>
             <a:endParaRPr lang="en-US"/>
           </a:p>
@@ -4788,7 +4737,7 @@
           <a:p>
             <a:fld id="{241EB5C9-1307-BA42-ABA2-0BC069CD8E7F}" type="datetimeFigureOut">
               <a:rPr lang="en-US" smtClean="0"/>
-              <a:t>3/23/2026</a:t>
+              <a:t>3/26/2026</a:t>
             </a:fld>
             <a:endParaRPr lang="en-US"/>
           </a:p>
@@ -5156,7 +5105,7 @@
           <a:p>
             <a:fld id="{241EB5C9-1307-BA42-ABA2-0BC069CD8E7F}" type="datetimeFigureOut">
               <a:rPr lang="en-US" smtClean="0"/>
-              <a:t>3/23/2026</a:t>
+              <a:t>3/26/2026</a:t>
             </a:fld>
             <a:endParaRPr lang="en-US"/>
           </a:p>
@@ -5533,7 +5482,7 @@
           <a:p>
             <a:fld id="{241EB5C9-1307-BA42-ABA2-0BC069CD8E7F}" type="datetimeFigureOut">
               <a:rPr lang="en-US" smtClean="0"/>
-              <a:t>3/23/2026</a:t>
+              <a:t>3/26/2026</a:t>
             </a:fld>
             <a:endParaRPr lang="en-US"/>
           </a:p>
@@ -5834,7 +5783,7 @@
           <a:p>
             <a:fld id="{241EB5C9-1307-BA42-ABA2-0BC069CD8E7F}" type="datetimeFigureOut">
               <a:rPr lang="en-US" smtClean="0"/>
-              <a:t>3/23/2026</a:t>
+              <a:t>3/26/2026</a:t>
             </a:fld>
             <a:endParaRPr lang="en-US"/>
           </a:p>
@@ -9559,16 +9508,262 @@
               <a:buNone/>
             </a:pPr>
             <a:r>
-              <a:t>Wenn Sie überall im Code </a:t>
-            </a:r>
-            <a:r>
-              <a:rPr>
+              <a:rPr dirty="0"/>
+              <a:t>Wenn Sie </a:t>
+            </a:r>
+            <a:r>
+              <a:rPr dirty="0" err="1"/>
+              <a:t>überall</a:t>
+            </a:r>
+            <a:r>
+              <a:rPr dirty="0"/>
+              <a:t> </a:t>
+            </a:r>
+            <a:r>
+              <a:rPr dirty="0" err="1"/>
+              <a:t>im</a:t>
+            </a:r>
+            <a:r>
+              <a:rPr dirty="0"/>
+              <a:t> Code </a:t>
+            </a:r>
+            <a:r>
+              <a:rPr dirty="0">
                 <a:latin typeface="Courier"/>
               </a:rPr>
-              <a:t>new BewilligungsBescheid()</a:t>
-            </a:r>
-            <a:r>
-              <a:t> schreiben, koppeln Sie Ihre Logik eng an diese konkrete Klasse. Was passiert, wenn sich der Prozess zur Erstellung ändert oder neue Bescheid-Arten oder -Varianten hinzukommen? Der Code wird unflexibel. Eine **lose Kopplung* ist die Lösung.</a:t>
+              <a:t>new </a:t>
+            </a:r>
+            <a:r>
+              <a:rPr dirty="0" err="1">
+                <a:latin typeface="Courier"/>
+              </a:rPr>
+              <a:t>BewilligungsBescheid</a:t>
+            </a:r>
+            <a:r>
+              <a:rPr dirty="0">
+                <a:latin typeface="Courier"/>
+              </a:rPr>
+              <a:t>()</a:t>
+            </a:r>
+            <a:r>
+              <a:rPr dirty="0"/>
+              <a:t> </a:t>
+            </a:r>
+            <a:r>
+              <a:rPr dirty="0" err="1"/>
+              <a:t>schreiben</a:t>
+            </a:r>
+            <a:r>
+              <a:rPr dirty="0"/>
+              <a:t>, </a:t>
+            </a:r>
+            <a:r>
+              <a:rPr dirty="0" err="1"/>
+              <a:t>koppeln</a:t>
+            </a:r>
+            <a:r>
+              <a:rPr dirty="0"/>
+              <a:t> Sie </a:t>
+            </a:r>
+            <a:r>
+              <a:rPr dirty="0" err="1"/>
+              <a:t>Ihre</a:t>
+            </a:r>
+            <a:r>
+              <a:rPr dirty="0"/>
+              <a:t> Logik </a:t>
+            </a:r>
+            <a:r>
+              <a:rPr dirty="0" err="1"/>
+              <a:t>eng</a:t>
+            </a:r>
+            <a:r>
+              <a:rPr dirty="0"/>
+              <a:t> an </a:t>
+            </a:r>
+            <a:r>
+              <a:rPr dirty="0" err="1"/>
+              <a:t>diese</a:t>
+            </a:r>
+            <a:r>
+              <a:rPr dirty="0"/>
+              <a:t> </a:t>
+            </a:r>
+            <a:r>
+              <a:rPr dirty="0" err="1"/>
+              <a:t>konkrete</a:t>
+            </a:r>
+            <a:r>
+              <a:rPr dirty="0"/>
+              <a:t> Klasse. </a:t>
+            </a:r>
+            <a:endParaRPr lang="de-DE" dirty="0"/>
+          </a:p>
+          <a:p>
+            <a:pPr marL="0" indent="0">
+              <a:buNone/>
+            </a:pPr>
+            <a:r>
+              <a:rPr dirty="0"/>
+              <a:t>Was </a:t>
+            </a:r>
+            <a:r>
+              <a:rPr dirty="0" err="1"/>
+              <a:t>passiert</a:t>
+            </a:r>
+            <a:r>
+              <a:rPr dirty="0"/>
+              <a:t>, </a:t>
+            </a:r>
+            <a:r>
+              <a:rPr dirty="0" err="1"/>
+              <a:t>wenn</a:t>
+            </a:r>
+            <a:r>
+              <a:rPr dirty="0"/>
+              <a:t> </a:t>
+            </a:r>
+            <a:r>
+              <a:rPr dirty="0" err="1"/>
+              <a:t>sich</a:t>
+            </a:r>
+            <a:r>
+              <a:rPr dirty="0"/>
+              <a:t> der </a:t>
+            </a:r>
+            <a:r>
+              <a:rPr dirty="0" err="1"/>
+              <a:t>Prozess</a:t>
+            </a:r>
+            <a:r>
+              <a:rPr dirty="0"/>
+              <a:t> </a:t>
+            </a:r>
+            <a:r>
+              <a:rPr dirty="0" err="1"/>
+              <a:t>zur</a:t>
+            </a:r>
+            <a:r>
+              <a:rPr dirty="0"/>
+              <a:t> </a:t>
+            </a:r>
+            <a:r>
+              <a:rPr dirty="0" err="1"/>
+              <a:t>Erstellung</a:t>
+            </a:r>
+            <a:r>
+              <a:rPr dirty="0"/>
+              <a:t> </a:t>
+            </a:r>
+            <a:r>
+              <a:rPr dirty="0" err="1"/>
+              <a:t>ändert</a:t>
+            </a:r>
+            <a:r>
+              <a:rPr dirty="0"/>
+              <a:t> </a:t>
+            </a:r>
+            <a:r>
+              <a:rPr dirty="0" err="1"/>
+              <a:t>oder</a:t>
+            </a:r>
+            <a:r>
+              <a:rPr dirty="0"/>
+              <a:t> </a:t>
+            </a:r>
+            <a:r>
+              <a:rPr dirty="0" err="1"/>
+              <a:t>neue</a:t>
+            </a:r>
+            <a:r>
+              <a:rPr dirty="0"/>
+              <a:t> </a:t>
+            </a:r>
+            <a:r>
+              <a:rPr dirty="0" err="1"/>
+              <a:t>Bescheid-Arten</a:t>
+            </a:r>
+            <a:r>
+              <a:rPr dirty="0"/>
+              <a:t> </a:t>
+            </a:r>
+            <a:r>
+              <a:rPr dirty="0" err="1"/>
+              <a:t>oder</a:t>
+            </a:r>
+            <a:r>
+              <a:rPr dirty="0"/>
+              <a:t> -</a:t>
+            </a:r>
+            <a:r>
+              <a:rPr dirty="0" err="1"/>
+              <a:t>Varianten</a:t>
+            </a:r>
+            <a:r>
+              <a:rPr dirty="0"/>
+              <a:t> </a:t>
+            </a:r>
+            <a:r>
+              <a:rPr dirty="0" err="1"/>
+              <a:t>hinzukommen</a:t>
+            </a:r>
+            <a:r>
+              <a:rPr dirty="0"/>
+              <a:t>? Der Code </a:t>
+            </a:r>
+            <a:r>
+              <a:rPr dirty="0" err="1"/>
+              <a:t>wird</a:t>
+            </a:r>
+            <a:r>
+              <a:rPr dirty="0"/>
+              <a:t> </a:t>
+            </a:r>
+            <a:r>
+              <a:rPr dirty="0" err="1"/>
+              <a:t>unflexibel</a:t>
+            </a:r>
+            <a:r>
+              <a:rPr dirty="0"/>
+              <a:t>. </a:t>
+            </a:r>
+            <a:endParaRPr lang="de-DE" dirty="0"/>
+          </a:p>
+          <a:p>
+            <a:pPr marL="0" indent="0">
+              <a:buNone/>
+            </a:pPr>
+            <a:r>
+              <a:rPr dirty="0"/>
+              <a:t>Eine </a:t>
+            </a:r>
+            <a:r>
+              <a:rPr b="1" dirty="0"/>
+              <a:t>lose </a:t>
+            </a:r>
+            <a:r>
+              <a:rPr b="1" dirty="0" err="1"/>
+              <a:t>Kopplung</a:t>
+            </a:r>
+            <a:r>
+              <a:rPr dirty="0"/>
+              <a:t> </a:t>
+            </a:r>
+            <a:r>
+              <a:rPr dirty="0" err="1"/>
+              <a:t>ist</a:t>
+            </a:r>
+            <a:r>
+              <a:rPr dirty="0"/>
+              <a:t> die </a:t>
+            </a:r>
+            <a:r>
+              <a:rPr dirty="0" err="1"/>
+              <a:t>Lösung</a:t>
+            </a:r>
+            <a:r>
+              <a:rPr dirty="0"/>
+              <a:t>.</a:t>
             </a:r>
           </a:p>
         </p:txBody>
@@ -27014,4 +27209,319 @@
     </a:ext>
   </a:extLst>
 </a:theme>
+</file>
+
+<file path=ppt/theme/theme2.xml><?xml version="1.0" encoding="utf-8"?>
+<a:theme xmlns:a="http://schemas.openxmlformats.org/drawingml/2006/main" name="Office">
+  <a:themeElements>
+    <a:clrScheme name="Office">
+      <a:dk1>
+        <a:sysClr val="windowText" lastClr="000000"/>
+      </a:dk1>
+      <a:lt1>
+        <a:sysClr val="window" lastClr="FFFFFF"/>
+      </a:lt1>
+      <a:dk2>
+        <a:srgbClr val="0E2841"/>
+      </a:dk2>
+      <a:lt2>
+        <a:srgbClr val="E8E8E8"/>
+      </a:lt2>
+      <a:accent1>
+        <a:srgbClr val="156082"/>
+      </a:accent1>
+      <a:accent2>
+        <a:srgbClr val="E97132"/>
+      </a:accent2>
+      <a:accent3>
+        <a:srgbClr val="196B24"/>
+      </a:accent3>
+      <a:accent4>
+        <a:srgbClr val="0F9ED5"/>
+      </a:accent4>
+      <a:accent5>
+        <a:srgbClr val="A02B93"/>
+      </a:accent5>
+      <a:accent6>
+        <a:srgbClr val="4EA72E"/>
+      </a:accent6>
+      <a:hlink>
+        <a:srgbClr val="467886"/>
+      </a:hlink>
+      <a:folHlink>
+        <a:srgbClr val="96607D"/>
+      </a:folHlink>
+    </a:clrScheme>
+    <a:fontScheme name="Office">
+      <a:majorFont>
+        <a:latin typeface="Aptos Display" panose="02110004020202020204"/>
+        <a:ea typeface=""/>
+        <a:cs typeface=""/>
+        <a:font script="Jpan" typeface="游ゴシック Light"/>
+        <a:font script="Hang" typeface="맑은 고딕"/>
+        <a:font script="Hans" typeface="等线 Light"/>
+        <a:font script="Hant" typeface="新細明體"/>
+        <a:font script="Arab" typeface="Times New Roman"/>
+        <a:font script="Hebr" typeface="Times New Roman"/>
+        <a:font script="Thai" typeface="Angsana New"/>
+        <a:font script="Ethi" typeface="Nyala"/>
+        <a:font script="Beng" typeface="Vrinda"/>
+        <a:font script="Gujr" typeface="Shruti"/>
+        <a:font script="Khmr" typeface="MoolBoran"/>
+        <a:font script="Knda" typeface="Tunga"/>
+        <a:font script="Guru" typeface="Raavi"/>
+        <a:font script="Cans" typeface="Euphemia"/>
+        <a:font script="Cher" typeface="Plantagenet Cherokee"/>
+        <a:font script="Yiii" typeface="Microsoft Yi Baiti"/>
+        <a:font script="Tibt" typeface="Microsoft Himalaya"/>
+        <a:font script="Thaa" typeface="MV Boli"/>
+        <a:font script="Deva" typeface="Mangal"/>
+        <a:font script="Telu" typeface="Gautami"/>
+        <a:font script="Taml" typeface="Latha"/>
+        <a:font script="Syrc" typeface="Estrangelo Edessa"/>
+        <a:font script="Orya" typeface="Kalinga"/>
+        <a:font script="Mlym" typeface="Kartika"/>
+        <a:font script="Laoo" typeface="DokChampa"/>
+        <a:font script="Sinh" typeface="Iskoola Pota"/>
+        <a:font script="Mong" typeface="Mongolian Baiti"/>
+        <a:font script="Viet" typeface="Times New Roman"/>
+        <a:font script="Uigh" typeface="Microsoft Uighur"/>
+        <a:font script="Geor" typeface="Sylfaen"/>
+        <a:font script="Armn" typeface="Arial"/>
+        <a:font script="Bugi" typeface="Leelawadee UI"/>
+        <a:font script="Bopo" typeface="Microsoft JhengHei"/>
+        <a:font script="Java" typeface="Javanese Text"/>
+        <a:font script="Lisu" typeface="Segoe UI"/>
+        <a:font script="Mymr" typeface="Myanmar Text"/>
+        <a:font script="Nkoo" typeface="Ebrima"/>
+        <a:font script="Olck" typeface="Nirmala UI"/>
+        <a:font script="Osma" typeface="Ebrima"/>
+        <a:font script="Phag" typeface="Phagspa"/>
+        <a:font script="Syrn" typeface="Estrangelo Edessa"/>
+        <a:font script="Syrj" typeface="Estrangelo Edessa"/>
+        <a:font script="Syre" typeface="Estrangelo Edessa"/>
+        <a:font script="Sora" typeface="Nirmala UI"/>
+        <a:font script="Tale" typeface="Microsoft Tai Le"/>
+        <a:font script="Talu" typeface="Microsoft New Tai Lue"/>
+        <a:font script="Tfng" typeface="Ebrima"/>
+      </a:majorFont>
+      <a:minorFont>
+        <a:latin typeface="Aptos" panose="02110004020202020204"/>
+        <a:ea typeface=""/>
+        <a:cs typeface=""/>
+        <a:font script="Jpan" typeface="游ゴシック"/>
+        <a:font script="Hang" typeface="맑은 고딕"/>
+        <a:font script="Hans" typeface="等线"/>
+        <a:font script="Hant" typeface="新細明體"/>
+        <a:font script="Arab" typeface="Arial"/>
+        <a:font script="Hebr" typeface="Arial"/>
+        <a:font script="Thai" typeface="Cordia New"/>
+        <a:font script="Ethi" typeface="Nyala"/>
+        <a:font script="Beng" typeface="Vrinda"/>
+        <a:font script="Gujr" typeface="Shruti"/>
+        <a:font script="Khmr" typeface="DaunPenh"/>
+        <a:font script="Knda" typeface="Tunga"/>
+        <a:font script="Guru" typeface="Raavi"/>
+        <a:font script="Cans" typeface="Euphemia"/>
+        <a:font script="Cher" typeface="Plantagenet Cherokee"/>
+        <a:font script="Yiii" typeface="Microsoft Yi Baiti"/>
+        <a:font script="Tibt" typeface="Microsoft Himalaya"/>
+        <a:font script="Thaa" typeface="MV Boli"/>
+        <a:font script="Deva" typeface="Mangal"/>
+        <a:font script="Telu" typeface="Gautami"/>
+        <a:font script="Taml" typeface="Latha"/>
+        <a:font script="Syrc" typeface="Estrangelo Edessa"/>
+        <a:font script="Orya" typeface="Kalinga"/>
+        <a:font script="Mlym" typeface="Kartika"/>
+        <a:font script="Laoo" typeface="DokChampa"/>
+        <a:font script="Sinh" typeface="Iskoola Pota"/>
+        <a:font script="Mong" typeface="Mongolian Baiti"/>
+        <a:font script="Viet" typeface="Arial"/>
+        <a:font script="Uigh" typeface="Microsoft Uighur"/>
+        <a:font script="Geor" typeface="Sylfaen"/>
+        <a:font script="Armn" typeface="Arial"/>
+        <a:font script="Bugi" typeface="Leelawadee UI"/>
+        <a:font script="Bopo" typeface="Microsoft JhengHei"/>
+        <a:font script="Java" typeface="Javanese Text"/>
+        <a:font script="Lisu" typeface="Segoe UI"/>
+        <a:font script="Mymr" typeface="Myanmar Text"/>
+        <a:font script="Nkoo" typeface="Ebrima"/>
+        <a:font script="Olck" typeface="Nirmala UI"/>
+        <a:font script="Osma" typeface="Ebrima"/>
+        <a:font script="Phag" typeface="Phagspa"/>
+        <a:font script="Syrn" typeface="Estrangelo Edessa"/>
+        <a:font script="Syrj" typeface="Estrangelo Edessa"/>
+        <a:font script="Syre" typeface="Estrangelo Edessa"/>
+        <a:font script="Sora" typeface="Nirmala UI"/>
+        <a:font script="Tale" typeface="Microsoft Tai Le"/>
+        <a:font script="Talu" typeface="Microsoft New Tai Lue"/>
+        <a:font script="Tfng" typeface="Ebrima"/>
+      </a:minorFont>
+    </a:fontScheme>
+    <a:fmtScheme name="Office">
+      <a:fillStyleLst>
+        <a:solidFill>
+          <a:schemeClr val="phClr"/>
+        </a:solidFill>
+        <a:gradFill rotWithShape="1">
+          <a:gsLst>
+            <a:gs pos="0">
+              <a:schemeClr val="phClr">
+                <a:lumMod val="110000"/>
+                <a:satMod val="105000"/>
+                <a:tint val="67000"/>
+              </a:schemeClr>
+            </a:gs>
+            <a:gs pos="50000">
+              <a:schemeClr val="phClr">
+                <a:lumMod val="105000"/>
+                <a:satMod val="103000"/>
+                <a:tint val="73000"/>
+              </a:schemeClr>
+            </a:gs>
+            <a:gs pos="100000">
+              <a:schemeClr val="phClr">
+                <a:lumMod val="105000"/>
+                <a:satMod val="109000"/>
+                <a:tint val="81000"/>
+              </a:schemeClr>
+            </a:gs>
+          </a:gsLst>
+          <a:lin ang="5400000" scaled="0"/>
+        </a:gradFill>
+        <a:gradFill rotWithShape="1">
+          <a:gsLst>
+            <a:gs pos="0">
+              <a:schemeClr val="phClr">
+                <a:satMod val="103000"/>
+                <a:lumMod val="102000"/>
+                <a:tint val="94000"/>
+              </a:schemeClr>
+            </a:gs>
+            <a:gs pos="50000">
+              <a:schemeClr val="phClr">
+                <a:satMod val="110000"/>
+                <a:lumMod val="100000"/>
+                <a:shade val="100000"/>
+              </a:schemeClr>
+            </a:gs>
+            <a:gs pos="100000">
+              <a:schemeClr val="phClr">
+                <a:lumMod val="99000"/>
+                <a:satMod val="120000"/>
+                <a:shade val="78000"/>
+              </a:schemeClr>
+            </a:gs>
+          </a:gsLst>
+          <a:lin ang="5400000" scaled="0"/>
+        </a:gradFill>
+      </a:fillStyleLst>
+      <a:lnStyleLst>
+        <a:ln w="12700" cap="flat" cmpd="sng" algn="ctr">
+          <a:solidFill>
+            <a:schemeClr val="phClr"/>
+          </a:solidFill>
+          <a:prstDash val="solid"/>
+          <a:miter lim="800000"/>
+        </a:ln>
+        <a:ln w="19050" cap="flat" cmpd="sng" algn="ctr">
+          <a:solidFill>
+            <a:schemeClr val="phClr"/>
+          </a:solidFill>
+          <a:prstDash val="solid"/>
+          <a:miter lim="800000"/>
+        </a:ln>
+        <a:ln w="25400" cap="flat" cmpd="sng" algn="ctr">
+          <a:solidFill>
+            <a:schemeClr val="phClr"/>
+          </a:solidFill>
+          <a:prstDash val="solid"/>
+          <a:miter lim="800000"/>
+        </a:ln>
+      </a:lnStyleLst>
+      <a:effectStyleLst>
+        <a:effectStyle>
+          <a:effectLst/>
+        </a:effectStyle>
+        <a:effectStyle>
+          <a:effectLst/>
+        </a:effectStyle>
+        <a:effectStyle>
+          <a:effectLst>
+            <a:outerShdw blurRad="57150" dist="19050" dir="5400000" algn="ctr" rotWithShape="0">
+              <a:srgbClr val="000000">
+                <a:alpha val="63000"/>
+              </a:srgbClr>
+            </a:outerShdw>
+          </a:effectLst>
+        </a:effectStyle>
+      </a:effectStyleLst>
+      <a:bgFillStyleLst>
+        <a:solidFill>
+          <a:schemeClr val="phClr"/>
+        </a:solidFill>
+        <a:solidFill>
+          <a:schemeClr val="phClr">
+            <a:tint val="95000"/>
+            <a:satMod val="170000"/>
+          </a:schemeClr>
+        </a:solidFill>
+        <a:gradFill rotWithShape="1">
+          <a:gsLst>
+            <a:gs pos="0">
+              <a:schemeClr val="phClr">
+                <a:tint val="93000"/>
+                <a:satMod val="150000"/>
+                <a:shade val="98000"/>
+                <a:lumMod val="102000"/>
+              </a:schemeClr>
+            </a:gs>
+            <a:gs pos="50000">
+              <a:schemeClr val="phClr">
+                <a:tint val="98000"/>
+                <a:satMod val="130000"/>
+                <a:shade val="90000"/>
+                <a:lumMod val="103000"/>
+              </a:schemeClr>
+            </a:gs>
+            <a:gs pos="100000">
+              <a:schemeClr val="phClr">
+                <a:shade val="63000"/>
+                <a:satMod val="120000"/>
+              </a:schemeClr>
+            </a:gs>
+          </a:gsLst>
+          <a:lin ang="5400000" scaled="0"/>
+        </a:gradFill>
+      </a:bgFillStyleLst>
+    </a:fmtScheme>
+  </a:themeElements>
+  <a:objectDefaults>
+    <a:lnDef>
+      <a:spPr/>
+      <a:bodyPr/>
+      <a:lstStyle/>
+      <a:style>
+        <a:lnRef idx="2">
+          <a:schemeClr val="accent1"/>
+        </a:lnRef>
+        <a:fillRef idx="0">
+          <a:schemeClr val="accent1"/>
+        </a:fillRef>
+        <a:effectRef idx="1">
+          <a:schemeClr val="accent1"/>
+        </a:effectRef>
+        <a:fontRef idx="minor">
+          <a:schemeClr val="tx1"/>
+        </a:fontRef>
+      </a:style>
+    </a:lnDef>
+  </a:objectDefaults>
+  <a:extraClrSchemeLst/>
+  <a:extLst>
+    <a:ext uri="{05A4C25C-085E-4340-85A3-A5531E510DB2}">
+      <thm15:themeFamily xmlns:thm15="http://schemas.microsoft.com/office/thememl/2012/main" name="Office Theme" id="{2E142A2C-CD16-42D6-873A-C26D2A0506FA}" vid="{1BDDFF52-6CD6-40A5-AB3C-68EB2F1E4D0A}"/>
+    </a:ext>
+  </a:extLst>
+</a:theme>
 </file>
</xml_diff>